<commit_message>
manipülasyonu bozmadan önceki hali.
</commit_message>
<xml_diff>
--- a/docs/output/Kripto_Kod_Kontrol_Otomasyon_Sistemi_Yetkili_Kullanici_Kilavuzu.pptx
+++ b/docs/output/Kripto_Kod_Kontrol_Otomasyon_Sistemi_Yetkili_Kullanici_Kilavuzu.pptx
@@ -118,6 +118,11 @@
       </a:defRPr>
     </a:lvl9pPr>
   </p:defaultTextStyle>
+  <p:extLst>
+    <p:ext uri="{EFAFB233-063F-42B5-8137-9DF3F51BA10A}">
+      <p15:sldGuideLst xmlns:p15="http://schemas.microsoft.com/office/powerpoint/2012/main"/>
+    </p:ext>
+  </p:extLst>
 </p:presentation>
 </file>
 
@@ -268,7 +273,7 @@
           <a:p>
             <a:fld id="{06BE0405-852A-45DA-9AE5-938FA56BDD69}" type="datetimeFigureOut">
               <a:rPr lang="tr-TR" smtClean="0"/>
-              <a:t>17.08.2026</a:t>
+              <a:t>8.09.2026</a:t>
             </a:fld>
             <a:endParaRPr lang="tr-TR"/>
           </a:p>
@@ -466,7 +471,7 @@
           <a:p>
             <a:fld id="{06BE0405-852A-45DA-9AE5-938FA56BDD69}" type="datetimeFigureOut">
               <a:rPr lang="tr-TR" smtClean="0"/>
-              <a:t>17.08.2026</a:t>
+              <a:t>8.09.2026</a:t>
             </a:fld>
             <a:endParaRPr lang="tr-TR"/>
           </a:p>
@@ -674,7 +679,7 @@
           <a:p>
             <a:fld id="{06BE0405-852A-45DA-9AE5-938FA56BDD69}" type="datetimeFigureOut">
               <a:rPr lang="tr-TR" smtClean="0"/>
-              <a:t>17.08.2026</a:t>
+              <a:t>8.09.2026</a:t>
             </a:fld>
             <a:endParaRPr lang="tr-TR"/>
           </a:p>
@@ -872,7 +877,7 @@
           <a:p>
             <a:fld id="{06BE0405-852A-45DA-9AE5-938FA56BDD69}" type="datetimeFigureOut">
               <a:rPr lang="tr-TR" smtClean="0"/>
-              <a:t>17.08.2026</a:t>
+              <a:t>8.09.2026</a:t>
             </a:fld>
             <a:endParaRPr lang="tr-TR"/>
           </a:p>
@@ -1147,7 +1152,7 @@
           <a:p>
             <a:fld id="{06BE0405-852A-45DA-9AE5-938FA56BDD69}" type="datetimeFigureOut">
               <a:rPr lang="tr-TR" smtClean="0"/>
-              <a:t>17.08.2026</a:t>
+              <a:t>8.09.2026</a:t>
             </a:fld>
             <a:endParaRPr lang="tr-TR"/>
           </a:p>
@@ -1412,7 +1417,7 @@
           <a:p>
             <a:fld id="{06BE0405-852A-45DA-9AE5-938FA56BDD69}" type="datetimeFigureOut">
               <a:rPr lang="tr-TR" smtClean="0"/>
-              <a:t>17.08.2026</a:t>
+              <a:t>8.09.2026</a:t>
             </a:fld>
             <a:endParaRPr lang="tr-TR"/>
           </a:p>
@@ -1824,7 +1829,7 @@
           <a:p>
             <a:fld id="{06BE0405-852A-45DA-9AE5-938FA56BDD69}" type="datetimeFigureOut">
               <a:rPr lang="tr-TR" smtClean="0"/>
-              <a:t>17.08.2026</a:t>
+              <a:t>8.09.2026</a:t>
             </a:fld>
             <a:endParaRPr lang="tr-TR"/>
           </a:p>
@@ -1965,7 +1970,7 @@
           <a:p>
             <a:fld id="{06BE0405-852A-45DA-9AE5-938FA56BDD69}" type="datetimeFigureOut">
               <a:rPr lang="tr-TR" smtClean="0"/>
-              <a:t>17.08.2026</a:t>
+              <a:t>8.09.2026</a:t>
             </a:fld>
             <a:endParaRPr lang="tr-TR"/>
           </a:p>
@@ -2078,7 +2083,7 @@
           <a:p>
             <a:fld id="{06BE0405-852A-45DA-9AE5-938FA56BDD69}" type="datetimeFigureOut">
               <a:rPr lang="tr-TR" smtClean="0"/>
-              <a:t>17.08.2026</a:t>
+              <a:t>8.09.2026</a:t>
             </a:fld>
             <a:endParaRPr lang="tr-TR"/>
           </a:p>
@@ -2389,7 +2394,7 @@
           <a:p>
             <a:fld id="{06BE0405-852A-45DA-9AE5-938FA56BDD69}" type="datetimeFigureOut">
               <a:rPr lang="tr-TR" smtClean="0"/>
-              <a:t>17.08.2026</a:t>
+              <a:t>8.09.2026</a:t>
             </a:fld>
             <a:endParaRPr lang="tr-TR"/>
           </a:p>
@@ -2677,7 +2682,7 @@
           <a:p>
             <a:fld id="{06BE0405-852A-45DA-9AE5-938FA56BDD69}" type="datetimeFigureOut">
               <a:rPr lang="tr-TR" smtClean="0"/>
-              <a:t>17.08.2026</a:t>
+              <a:t>8.09.2026</a:t>
             </a:fld>
             <a:endParaRPr lang="tr-TR"/>
           </a:p>
@@ -2918,7 +2923,7 @@
           <a:p>
             <a:fld id="{06BE0405-852A-45DA-9AE5-938FA56BDD69}" type="datetimeFigureOut">
               <a:rPr lang="tr-TR" smtClean="0"/>
-              <a:t>17.08.2026</a:t>
+              <a:t>8.09.2026</a:t>
             </a:fld>
             <a:endParaRPr lang="tr-TR"/>
           </a:p>
@@ -4764,7 +4769,7 @@
         </p:nvSpPr>
         <p:spPr>
           <a:xfrm>
-            <a:off x="5760720" y="2788920"/>
+            <a:off x="5833872" y="1463041"/>
             <a:ext cx="329184" cy="329184"/>
           </a:xfrm>
           <a:prstGeom prst="ellipse">
@@ -4826,7 +4831,7 @@
         </p:nvSpPr>
         <p:spPr>
           <a:xfrm>
-            <a:off x="10652760" y="4754880"/>
+            <a:off x="10917936" y="4553712"/>
             <a:ext cx="329184" cy="329184"/>
           </a:xfrm>
           <a:prstGeom prst="ellipse">
@@ -5570,7 +5575,7 @@
         </p:nvSpPr>
         <p:spPr>
           <a:xfrm>
-            <a:off x="1965960" y="1737360"/>
+            <a:off x="2029968" y="2233815"/>
             <a:ext cx="329184" cy="329184"/>
           </a:xfrm>
           <a:prstGeom prst="ellipse">
@@ -5632,7 +5637,7 @@
         </p:nvSpPr>
         <p:spPr>
           <a:xfrm>
-            <a:off x="4434840" y="1737360"/>
+            <a:off x="3456432" y="2514600"/>
             <a:ext cx="329184" cy="329184"/>
           </a:xfrm>
           <a:prstGeom prst="ellipse">
@@ -5694,7 +5699,7 @@
         </p:nvSpPr>
         <p:spPr>
           <a:xfrm>
-            <a:off x="6629400" y="1737360"/>
+            <a:off x="5856732" y="2514600"/>
             <a:ext cx="329184" cy="329184"/>
           </a:xfrm>
           <a:prstGeom prst="ellipse">
@@ -5756,7 +5761,7 @@
         </p:nvSpPr>
         <p:spPr>
           <a:xfrm>
-            <a:off x="6629400" y="2880360"/>
+            <a:off x="6809994" y="2909131"/>
             <a:ext cx="329184" cy="329184"/>
           </a:xfrm>
           <a:prstGeom prst="ellipse">
@@ -5818,7 +5823,7 @@
         </p:nvSpPr>
         <p:spPr>
           <a:xfrm>
-            <a:off x="4160520" y="4617720"/>
+            <a:off x="649224" y="2909131"/>
             <a:ext cx="329184" cy="329184"/>
           </a:xfrm>
           <a:prstGeom prst="ellipse">
@@ -6988,7 +6993,7 @@
         </p:nvSpPr>
         <p:spPr>
           <a:xfrm>
-            <a:off x="3749040" y="1572768"/>
+            <a:off x="3767328" y="1760864"/>
             <a:ext cx="329184" cy="329184"/>
           </a:xfrm>
           <a:prstGeom prst="ellipse">
@@ -7025,7 +7030,7 @@
           <a:p>
             <a:pPr algn="ctr"/>
             <a:r>
-              <a:rPr lang="tr-TR" sz="900" b="1">
+              <a:rPr lang="tr-TR" sz="900" b="1" dirty="0">
                 <a:solidFill>
                   <a:srgbClr val="FFFFFF"/>
                 </a:solidFill>
@@ -7050,7 +7055,7 @@
         </p:nvSpPr>
         <p:spPr>
           <a:xfrm>
-            <a:off x="3749040" y="2286000"/>
+            <a:off x="3767328" y="2617863"/>
             <a:ext cx="329184" cy="329184"/>
           </a:xfrm>
           <a:prstGeom prst="ellipse">
@@ -7112,7 +7117,7 @@
         </p:nvSpPr>
         <p:spPr>
           <a:xfrm>
-            <a:off x="3749040" y="3200400"/>
+            <a:off x="3762756" y="3393693"/>
             <a:ext cx="329184" cy="329184"/>
           </a:xfrm>
           <a:prstGeom prst="ellipse">
@@ -7174,7 +7179,7 @@
         </p:nvSpPr>
         <p:spPr>
           <a:xfrm>
-            <a:off x="2286000" y="4800600"/>
+            <a:off x="1856232" y="4262443"/>
             <a:ext cx="329184" cy="329184"/>
           </a:xfrm>
           <a:prstGeom prst="ellipse">
@@ -7236,7 +7241,7 @@
         </p:nvSpPr>
         <p:spPr>
           <a:xfrm>
-            <a:off x="5577840" y="4800600"/>
+            <a:off x="5669280" y="4262443"/>
             <a:ext cx="329184" cy="329184"/>
           </a:xfrm>
           <a:prstGeom prst="ellipse">
@@ -8406,7 +8411,7 @@
         </p:nvSpPr>
         <p:spPr>
           <a:xfrm>
-            <a:off x="10469880" y="1664208"/>
+            <a:off x="11064240" y="1874520"/>
             <a:ext cx="329184" cy="329184"/>
           </a:xfrm>
           <a:prstGeom prst="ellipse">
@@ -8468,7 +8473,7 @@
         </p:nvSpPr>
         <p:spPr>
           <a:xfrm>
-            <a:off x="2148840" y="2834640"/>
+            <a:off x="2505456" y="2532888"/>
             <a:ext cx="329184" cy="329184"/>
           </a:xfrm>
           <a:prstGeom prst="ellipse">
@@ -8530,7 +8535,7 @@
         </p:nvSpPr>
         <p:spPr>
           <a:xfrm>
-            <a:off x="4069080" y="2834640"/>
+            <a:off x="4575049" y="2532888"/>
             <a:ext cx="329184" cy="329184"/>
           </a:xfrm>
           <a:prstGeom prst="ellipse">
@@ -8592,7 +8597,7 @@
         </p:nvSpPr>
         <p:spPr>
           <a:xfrm>
-            <a:off x="7452360" y="2834640"/>
+            <a:off x="8668512" y="2532888"/>
             <a:ext cx="329184" cy="329184"/>
           </a:xfrm>
           <a:prstGeom prst="ellipse">
@@ -8654,7 +8659,7 @@
         </p:nvSpPr>
         <p:spPr>
           <a:xfrm>
-            <a:off x="9921240" y="2834640"/>
+            <a:off x="10287000" y="2532888"/>
             <a:ext cx="329184" cy="329184"/>
           </a:xfrm>
           <a:prstGeom prst="ellipse">
@@ -8691,7 +8696,7 @@
           <a:p>
             <a:pPr algn="ctr"/>
             <a:r>
-              <a:rPr lang="tr-TR" sz="900" b="1">
+              <a:rPr lang="tr-TR" sz="900" b="1" dirty="0">
                 <a:solidFill>
                   <a:srgbClr val="FFFFFF"/>
                 </a:solidFill>
@@ -9824,7 +9829,7 @@
         </p:nvSpPr>
         <p:spPr>
           <a:xfrm>
-            <a:off x="4572000" y="2606040"/>
+            <a:off x="5669280" y="1359777"/>
             <a:ext cx="329184" cy="329184"/>
           </a:xfrm>
           <a:prstGeom prst="ellipse">
@@ -9886,7 +9891,7 @@
         </p:nvSpPr>
         <p:spPr>
           <a:xfrm>
-            <a:off x="10561320" y="1508760"/>
+            <a:off x="11064240" y="1807834"/>
             <a:ext cx="329183" cy="329184"/>
           </a:xfrm>
           <a:prstGeom prst="ellipse">
@@ -9923,7 +9928,7 @@
           <a:p>
             <a:pPr algn="ctr"/>
             <a:r>
-              <a:rPr lang="tr-TR" sz="900" b="1">
+              <a:rPr lang="tr-TR" sz="900" b="1" dirty="0">
                 <a:solidFill>
                   <a:srgbClr val="FFFFFF"/>
                 </a:solidFill>
@@ -9948,7 +9953,7 @@
         </p:nvSpPr>
         <p:spPr>
           <a:xfrm>
-            <a:off x="10469880" y="2743200"/>
+            <a:off x="11064240" y="2555747"/>
             <a:ext cx="329184" cy="329184"/>
           </a:xfrm>
           <a:prstGeom prst="ellipse">
@@ -9985,7 +9990,7 @@
           <a:p>
             <a:pPr algn="ctr"/>
             <a:r>
-              <a:rPr lang="tr-TR" sz="900" b="1">
+              <a:rPr lang="tr-TR" sz="900" b="1" dirty="0">
                 <a:solidFill>
                   <a:srgbClr val="FFFFFF"/>
                 </a:solidFill>
@@ -10010,7 +10015,7 @@
         </p:nvSpPr>
         <p:spPr>
           <a:xfrm>
-            <a:off x="6400800" y="2743200"/>
+            <a:off x="6007608" y="2555747"/>
             <a:ext cx="329184" cy="329184"/>
           </a:xfrm>
           <a:prstGeom prst="ellipse">
@@ -11038,7 +11043,7 @@
         </p:nvSpPr>
         <p:spPr>
           <a:xfrm>
-            <a:off x="9829800" y="1737360"/>
+            <a:off x="10936224" y="1930723"/>
             <a:ext cx="310896" cy="310896"/>
           </a:xfrm>
           <a:prstGeom prst="ellipse">
@@ -11100,7 +11105,7 @@
         </p:nvSpPr>
         <p:spPr>
           <a:xfrm>
-            <a:off x="9829800" y="2788920"/>
+            <a:off x="10936224" y="2525083"/>
             <a:ext cx="310896" cy="310896"/>
           </a:xfrm>
           <a:prstGeom prst="ellipse">
@@ -11137,7 +11142,7 @@
           <a:p>
             <a:pPr algn="ctr"/>
             <a:r>
-              <a:rPr lang="tr-TR" sz="900" b="1">
+              <a:rPr lang="tr-TR" sz="900" b="1" dirty="0">
                 <a:solidFill>
                   <a:srgbClr val="FFFFFF"/>
                 </a:solidFill>
@@ -11162,7 +11167,7 @@
         </p:nvSpPr>
         <p:spPr>
           <a:xfrm>
-            <a:off x="9829800" y="3703320"/>
+            <a:off x="10936224" y="3029343"/>
             <a:ext cx="310896" cy="310896"/>
           </a:xfrm>
           <a:prstGeom prst="ellipse">
@@ -11199,7 +11204,7 @@
           <a:p>
             <a:pPr algn="ctr"/>
             <a:r>
-              <a:rPr lang="tr-TR" sz="900" b="1">
+              <a:rPr lang="tr-TR" sz="900" b="1" dirty="0">
                 <a:solidFill>
                   <a:srgbClr val="FFFFFF"/>
                 </a:solidFill>
@@ -11224,7 +11229,7 @@
         </p:nvSpPr>
         <p:spPr>
           <a:xfrm>
-            <a:off x="9829800" y="4892040"/>
+            <a:off x="9518904" y="3621024"/>
             <a:ext cx="310896" cy="310896"/>
           </a:xfrm>
           <a:prstGeom prst="ellipse">
@@ -11261,7 +11266,7 @@
           <a:p>
             <a:pPr algn="ctr"/>
             <a:r>
-              <a:rPr lang="tr-TR" sz="900" b="1">
+              <a:rPr lang="tr-TR" sz="900" b="1" dirty="0">
                 <a:solidFill>
                   <a:srgbClr val="FFFFFF"/>
                 </a:solidFill>
@@ -12252,7 +12257,7 @@
         </p:nvSpPr>
         <p:spPr>
           <a:xfrm>
-            <a:off x="4023360" y="1874520"/>
+            <a:off x="4183380" y="1852058"/>
             <a:ext cx="329184" cy="329184"/>
           </a:xfrm>
           <a:prstGeom prst="ellipse">
@@ -12314,7 +12319,7 @@
         </p:nvSpPr>
         <p:spPr>
           <a:xfrm>
-            <a:off x="4023360" y="2788920"/>
+            <a:off x="4183380" y="3644836"/>
             <a:ext cx="329184" cy="329184"/>
           </a:xfrm>
           <a:prstGeom prst="ellipse">
@@ -12364,10 +12369,10 @@
       </p:sp>
       <p:sp>
         <p:nvSpPr>
-          <p:cNvPr id="13" name="Oval 12">
-            <a:extLst>
-              <a:ext uri="{FF2B5EF4-FFF2-40B4-BE49-F238E27FC236}">
-                <a16:creationId xmlns:a16="http://schemas.microsoft.com/office/drawing/2014/main" id="{CB897542-2A5B-F1F9-A75F-089738744336}"/>
+          <p:cNvPr id="14" name="Oval 13">
+            <a:extLst>
+              <a:ext uri="{FF2B5EF4-FFF2-40B4-BE49-F238E27FC236}">
+                <a16:creationId xmlns:a16="http://schemas.microsoft.com/office/drawing/2014/main" id="{4D51684B-655B-D553-3480-066E8B4D0C57}"/>
               </a:ext>
             </a:extLst>
           </p:cNvPr>
@@ -12376,69 +12381,7 @@
         </p:nvSpPr>
         <p:spPr>
           <a:xfrm>
-            <a:off x="4023360" y="4315968"/>
-            <a:ext cx="329184" cy="329184"/>
-          </a:xfrm>
-          <a:prstGeom prst="ellipse">
-            <a:avLst/>
-          </a:prstGeom>
-          <a:solidFill>
-            <a:srgbClr val="F05B5B"/>
-          </a:solidFill>
-          <a:ln w="19050">
-            <a:solidFill>
-              <a:srgbClr val="FFFFFF"/>
-            </a:solidFill>
-          </a:ln>
-        </p:spPr>
-        <p:style>
-          <a:lnRef idx="2">
-            <a:schemeClr val="accent1">
-              <a:shade val="15000"/>
-            </a:schemeClr>
-          </a:lnRef>
-          <a:fillRef idx="1">
-            <a:schemeClr val="accent1"/>
-          </a:fillRef>
-          <a:effectRef idx="0">
-            <a:schemeClr val="accent1"/>
-          </a:effectRef>
-          <a:fontRef idx="minor">
-            <a:schemeClr val="lt1"/>
-          </a:fontRef>
-        </p:style>
-        <p:txBody>
-          <a:bodyPr lIns="0" tIns="0" rIns="0" bIns="0" rtlCol="0" anchor="ctr"/>
-          <a:lstStyle/>
-          <a:p>
-            <a:pPr algn="ctr"/>
-            <a:r>
-              <a:rPr lang="tr-TR" sz="900" b="1">
-                <a:solidFill>
-                  <a:srgbClr val="FFFFFF"/>
-                </a:solidFill>
-                <a:latin typeface="Aptos" panose="020B0004020202020204" pitchFamily="34" charset="0"/>
-              </a:rPr>
-              <a:t>3</a:t>
-            </a:r>
-          </a:p>
-        </p:txBody>
-      </p:sp>
-      <p:sp>
-        <p:nvSpPr>
-          <p:cNvPr id="14" name="Oval 13">
-            <a:extLst>
-              <a:ext uri="{FF2B5EF4-FFF2-40B4-BE49-F238E27FC236}">
-                <a16:creationId xmlns:a16="http://schemas.microsoft.com/office/drawing/2014/main" id="{4D51684B-655B-D553-3480-066E8B4D0C57}"/>
-              </a:ext>
-            </a:extLst>
-          </p:cNvPr>
-          <p:cNvSpPr/>
-          <p:nvPr/>
-        </p:nvSpPr>
-        <p:spPr>
-          <a:xfrm>
-            <a:off x="8458200" y="1417320"/>
+            <a:off x="8458200" y="1901952"/>
             <a:ext cx="310896" cy="310896"/>
           </a:xfrm>
           <a:prstGeom prst="ellipse">
@@ -12500,7 +12443,7 @@
         </p:nvSpPr>
         <p:spPr>
           <a:xfrm>
-            <a:off x="8887968" y="1408176"/>
+            <a:off x="8887968" y="1892808"/>
             <a:ext cx="2816352" cy="276999"/>
           </a:xfrm>
           <a:prstGeom prst="rect">
@@ -12540,7 +12483,7 @@
         </p:nvSpPr>
         <p:spPr>
           <a:xfrm>
-            <a:off x="8887968" y="1645920"/>
+            <a:off x="8887968" y="2130552"/>
             <a:ext cx="2816352" cy="276999"/>
           </a:xfrm>
           <a:prstGeom prst="rect">
@@ -12555,13 +12498,67 @@
           <a:lstStyle/>
           <a:p>
             <a:r>
-              <a:rPr lang="tr-TR" sz="820">
+              <a:rPr lang="tr-TR" sz="820" dirty="0">
                 <a:solidFill>
                   <a:srgbClr val="66788A"/>
                 </a:solidFill>
                 <a:latin typeface="Aptos" panose="020B0004020202020204" pitchFamily="34" charset="0"/>
               </a:rPr>
-              <a:t>Toplam Kod, Üretilen, Fire ve Reject Kurtarma sayılarını birlikte gösterir.</a:t>
+              <a:t>Toplam Kod, Üretilen, Fire, </a:t>
+            </a:r>
+            <a:r>
+              <a:rPr lang="tr-TR" sz="820" dirty="0" err="1">
+                <a:solidFill>
+                  <a:srgbClr val="66788A"/>
+                </a:solidFill>
+                <a:latin typeface="Aptos" panose="020B0004020202020204" pitchFamily="34" charset="0"/>
+              </a:rPr>
+              <a:t>Reject</a:t>
+            </a:r>
+            <a:r>
+              <a:rPr lang="tr-TR" sz="820" dirty="0">
+                <a:solidFill>
+                  <a:srgbClr val="66788A"/>
+                </a:solidFill>
+                <a:latin typeface="Aptos" panose="020B0004020202020204" pitchFamily="34" charset="0"/>
+              </a:rPr>
+              <a:t> Kurtarma, </a:t>
+            </a:r>
+            <a:r>
+              <a:rPr lang="tr-TR" sz="820" dirty="0" err="1">
+                <a:solidFill>
+                  <a:srgbClr val="66788A"/>
+                </a:solidFill>
+                <a:latin typeface="Aptos" panose="020B0004020202020204" pitchFamily="34" charset="0"/>
+              </a:rPr>
+              <a:t>Available</a:t>
+            </a:r>
+            <a:r>
+              <a:rPr lang="tr-TR" sz="820" dirty="0">
+                <a:solidFill>
+                  <a:srgbClr val="66788A"/>
+                </a:solidFill>
+                <a:latin typeface="Aptos" panose="020B0004020202020204" pitchFamily="34" charset="0"/>
+              </a:rPr>
+              <a:t>, </a:t>
+            </a:r>
+            <a:r>
+              <a:rPr lang="tr-TR" sz="820" dirty="0" err="1">
+                <a:solidFill>
+                  <a:srgbClr val="66788A"/>
+                </a:solidFill>
+                <a:latin typeface="Aptos" panose="020B0004020202020204" pitchFamily="34" charset="0"/>
+              </a:rPr>
+              <a:t>Allocated</a:t>
+            </a:r>
+            <a:r>
+              <a:rPr lang="tr-TR" sz="820" dirty="0">
+                <a:solidFill>
+                  <a:srgbClr val="66788A"/>
+                </a:solidFill>
+                <a:latin typeface="Aptos" panose="020B0004020202020204" pitchFamily="34" charset="0"/>
+              </a:rPr>
+              <a:t> sayılarını birlikte gösterir.</a:t>
             </a:r>
           </a:p>
         </p:txBody>
@@ -12580,7 +12577,7 @@
         </p:nvSpPr>
         <p:spPr>
           <a:xfrm>
-            <a:off x="8458200" y="2834640"/>
+            <a:off x="8458200" y="3319272"/>
             <a:ext cx="310896" cy="310896"/>
           </a:xfrm>
           <a:prstGeom prst="ellipse">
@@ -12642,7 +12639,7 @@
         </p:nvSpPr>
         <p:spPr>
           <a:xfrm>
-            <a:off x="8887968" y="2825496"/>
+            <a:off x="8887968" y="3310128"/>
             <a:ext cx="2816352" cy="276999"/>
           </a:xfrm>
           <a:prstGeom prst="rect">
@@ -12657,13 +12654,13 @@
           <a:lstStyle/>
           <a:p>
             <a:r>
-              <a:rPr lang="tr-TR" sz="1030" b="1">
+              <a:rPr lang="tr-TR" sz="1030" b="1" dirty="0">
                 <a:solidFill>
                   <a:srgbClr val="4B5F73"/>
                 </a:solidFill>
                 <a:latin typeface="Aptos" panose="020B0004020202020204" pitchFamily="34" charset="0"/>
               </a:rPr>
-              <a:t>Available / Allocated / Void</a:t>
+              <a:t>Satış siparişleri</a:t>
             </a:r>
           </a:p>
         </p:txBody>
@@ -12682,7 +12679,7 @@
         </p:nvSpPr>
         <p:spPr>
           <a:xfrm>
-            <a:off x="8887968" y="3063240"/>
+            <a:off x="8887968" y="3547872"/>
             <a:ext cx="2816352" cy="276999"/>
           </a:xfrm>
           <a:prstGeom prst="rect">
@@ -12697,149 +12694,7 @@
           <a:lstStyle/>
           <a:p>
             <a:r>
-              <a:rPr lang="tr-TR" sz="820">
-                <a:solidFill>
-                  <a:srgbClr val="66788A"/>
-                </a:solidFill>
-                <a:latin typeface="Aptos" panose="020B0004020202020204" pitchFamily="34" charset="0"/>
-              </a:rPr>
-              <a:t>Available kullanılabilir, Allocated planlı siparişe ayrılmış, Void geçersiz veya kullanılamayacak koddur.</a:t>
-            </a:r>
-          </a:p>
-        </p:txBody>
-      </p:sp>
-      <p:sp>
-        <p:nvSpPr>
-          <p:cNvPr id="20" name="Oval 19">
-            <a:extLst>
-              <a:ext uri="{FF2B5EF4-FFF2-40B4-BE49-F238E27FC236}">
-                <a16:creationId xmlns:a16="http://schemas.microsoft.com/office/drawing/2014/main" id="{194143E6-0D02-BD8C-AE7A-6D67C7B8CFBA}"/>
-              </a:ext>
-            </a:extLst>
-          </p:cNvPr>
-          <p:cNvSpPr/>
-          <p:nvPr/>
-        </p:nvSpPr>
-        <p:spPr>
-          <a:xfrm>
-            <a:off x="8458200" y="4251960"/>
-            <a:ext cx="310896" cy="310896"/>
-          </a:xfrm>
-          <a:prstGeom prst="ellipse">
-            <a:avLst/>
-          </a:prstGeom>
-          <a:solidFill>
-            <a:srgbClr val="F05B5B"/>
-          </a:solidFill>
-          <a:ln w="19050">
-            <a:solidFill>
-              <a:srgbClr val="FFFFFF"/>
-            </a:solidFill>
-          </a:ln>
-        </p:spPr>
-        <p:style>
-          <a:lnRef idx="2">
-            <a:schemeClr val="accent1">
-              <a:shade val="15000"/>
-            </a:schemeClr>
-          </a:lnRef>
-          <a:fillRef idx="1">
-            <a:schemeClr val="accent1"/>
-          </a:fillRef>
-          <a:effectRef idx="0">
-            <a:schemeClr val="accent1"/>
-          </a:effectRef>
-          <a:fontRef idx="minor">
-            <a:schemeClr val="lt1"/>
-          </a:fontRef>
-        </p:style>
-        <p:txBody>
-          <a:bodyPr lIns="0" tIns="0" rIns="0" bIns="0" rtlCol="0" anchor="ctr"/>
-          <a:lstStyle/>
-          <a:p>
-            <a:pPr algn="ctr"/>
-            <a:r>
-              <a:rPr lang="tr-TR" sz="900" b="1">
-                <a:solidFill>
-                  <a:srgbClr val="FFFFFF"/>
-                </a:solidFill>
-                <a:latin typeface="Aptos" panose="020B0004020202020204" pitchFamily="34" charset="0"/>
-              </a:rPr>
-              <a:t>3</a:t>
-            </a:r>
-          </a:p>
-        </p:txBody>
-      </p:sp>
-      <p:sp>
-        <p:nvSpPr>
-          <p:cNvPr id="21" name="Metin kutusu 20">
-            <a:extLst>
-              <a:ext uri="{FF2B5EF4-FFF2-40B4-BE49-F238E27FC236}">
-                <a16:creationId xmlns:a16="http://schemas.microsoft.com/office/drawing/2014/main" id="{65B5248B-8956-A753-63DF-410BC1FF0C55}"/>
-              </a:ext>
-            </a:extLst>
-          </p:cNvPr>
-          <p:cNvSpPr txBox="1"/>
-          <p:nvPr/>
-        </p:nvSpPr>
-        <p:spPr>
-          <a:xfrm>
-            <a:off x="8887968" y="4242816"/>
-            <a:ext cx="2816352" cy="276999"/>
-          </a:xfrm>
-          <a:prstGeom prst="rect">
-            <a:avLst/>
-          </a:prstGeom>
-          <a:noFill/>
-        </p:spPr>
-        <p:txBody>
-          <a:bodyPr vert="horz" wrap="square" lIns="0" tIns="0" rIns="0" bIns="0" rtlCol="0" anchor="t">
-            <a:noAutofit/>
-          </a:bodyPr>
-          <a:lstStyle/>
-          <a:p>
-            <a:r>
-              <a:rPr lang="tr-TR" sz="1030" b="1">
-                <a:solidFill>
-                  <a:srgbClr val="4B5F73"/>
-                </a:solidFill>
-                <a:latin typeface="Aptos" panose="020B0004020202020204" pitchFamily="34" charset="0"/>
-              </a:rPr>
-              <a:t>Satış siparişleri</a:t>
-            </a:r>
-          </a:p>
-        </p:txBody>
-      </p:sp>
-      <p:sp>
-        <p:nvSpPr>
-          <p:cNvPr id="22" name="Metin kutusu 21">
-            <a:extLst>
-              <a:ext uri="{FF2B5EF4-FFF2-40B4-BE49-F238E27FC236}">
-                <a16:creationId xmlns:a16="http://schemas.microsoft.com/office/drawing/2014/main" id="{CD11DB49-A57B-2A5C-49F4-B86991454A27}"/>
-              </a:ext>
-            </a:extLst>
-          </p:cNvPr>
-          <p:cNvSpPr txBox="1"/>
-          <p:nvPr/>
-        </p:nvSpPr>
-        <p:spPr>
-          <a:xfrm>
-            <a:off x="8887968" y="4480560"/>
-            <a:ext cx="2816352" cy="276999"/>
-          </a:xfrm>
-          <a:prstGeom prst="rect">
-            <a:avLst/>
-          </a:prstGeom>
-          <a:noFill/>
-        </p:spPr>
-        <p:txBody>
-          <a:bodyPr vert="horz" wrap="square" lIns="0" tIns="0" rIns="0" bIns="0" rtlCol="0" anchor="t">
-            <a:noAutofit/>
-          </a:bodyPr>
-          <a:lstStyle/>
-          <a:p>
-            <a:r>
-              <a:rPr lang="tr-TR" sz="820">
+              <a:rPr lang="tr-TR" sz="820" dirty="0">
                 <a:solidFill>
                   <a:srgbClr val="66788A"/>
                 </a:solidFill>
@@ -13262,7 +13117,7 @@
         </p:nvSpPr>
         <p:spPr>
           <a:xfrm>
-            <a:off x="3794760" y="2057400"/>
+            <a:off x="4443984" y="1792225"/>
             <a:ext cx="329184" cy="329184"/>
           </a:xfrm>
           <a:prstGeom prst="ellipse">
@@ -13324,7 +13179,7 @@
         </p:nvSpPr>
         <p:spPr>
           <a:xfrm>
-            <a:off x="6537960" y="1874520"/>
+            <a:off x="6848856" y="1792225"/>
             <a:ext cx="329184" cy="329184"/>
           </a:xfrm>
           <a:prstGeom prst="ellipse">
@@ -13361,7 +13216,7 @@
           <a:p>
             <a:pPr algn="ctr"/>
             <a:r>
-              <a:rPr lang="tr-TR" sz="900" b="1">
+              <a:rPr lang="tr-TR" sz="900" b="1" dirty="0">
                 <a:solidFill>
                   <a:srgbClr val="FFFFFF"/>
                 </a:solidFill>
@@ -13386,7 +13241,7 @@
         </p:nvSpPr>
         <p:spPr>
           <a:xfrm>
-            <a:off x="3840480" y="4663440"/>
+            <a:off x="4443984" y="4026038"/>
             <a:ext cx="329184" cy="329184"/>
           </a:xfrm>
           <a:prstGeom prst="ellipse">
@@ -13423,7 +13278,7 @@
           <a:p>
             <a:pPr algn="ctr"/>
             <a:r>
-              <a:rPr lang="tr-TR" sz="900" b="1">
+              <a:rPr lang="tr-TR" sz="900" b="1" dirty="0">
                 <a:solidFill>
                   <a:srgbClr val="FFFFFF"/>
                 </a:solidFill>
@@ -13667,7 +13522,7 @@
           <a:lstStyle/>
           <a:p>
             <a:r>
-              <a:rPr lang="tr-TR" sz="1030" b="1">
+              <a:rPr lang="tr-TR" sz="1030" b="1" dirty="0">
                 <a:solidFill>
                   <a:srgbClr val="4B5F73"/>
                 </a:solidFill>
@@ -13693,7 +13548,7 @@
         <p:spPr>
           <a:xfrm>
             <a:off x="8796528" y="3063240"/>
-            <a:ext cx="2953512" cy="276999"/>
+            <a:ext cx="2953512" cy="1033272"/>
           </a:xfrm>
           <a:prstGeom prst="rect">
             <a:avLst/>
@@ -13707,13 +13562,162 @@
           <a:lstStyle/>
           <a:p>
             <a:r>
-              <a:rPr lang="tr-TR" sz="820">
+              <a:rPr lang="tr-TR" sz="820" b="1" dirty="0" err="1">
                 <a:solidFill>
                   <a:srgbClr val="66788A"/>
                 </a:solidFill>
                 <a:latin typeface="Aptos" panose="020B0004020202020204" pitchFamily="34" charset="0"/>
               </a:rPr>
-              <a:t>ProducedOk üretilmiş, Reject reject durumunda, Scrap fireye ayrılmış kodları ifade eder.</a:t>
+              <a:t>Available</a:t>
+            </a:r>
+            <a:r>
+              <a:rPr lang="tr-TR" sz="820" dirty="0">
+                <a:solidFill>
+                  <a:srgbClr val="66788A"/>
+                </a:solidFill>
+                <a:latin typeface="Aptos" panose="020B0004020202020204" pitchFamily="34" charset="0"/>
+              </a:rPr>
+              <a:t>, henüz herhangi bir planlı siparişe atanmamış ve kullanıma hazır;</a:t>
+            </a:r>
+            <a:br>
+              <a:rPr lang="tr-TR" sz="820" dirty="0">
+                <a:solidFill>
+                  <a:srgbClr val="66788A"/>
+                </a:solidFill>
+                <a:latin typeface="Aptos" panose="020B0004020202020204" pitchFamily="34" charset="0"/>
+              </a:rPr>
+            </a:br>
+            <a:r>
+              <a:rPr lang="tr-TR" sz="820" b="1" dirty="0" err="1">
+                <a:solidFill>
+                  <a:srgbClr val="66788A"/>
+                </a:solidFill>
+                <a:latin typeface="Aptos" panose="020B0004020202020204" pitchFamily="34" charset="0"/>
+              </a:rPr>
+              <a:t>Allocated</a:t>
+            </a:r>
+            <a:r>
+              <a:rPr lang="tr-TR" sz="820" dirty="0">
+                <a:solidFill>
+                  <a:srgbClr val="66788A"/>
+                </a:solidFill>
+                <a:latin typeface="Aptos" panose="020B0004020202020204" pitchFamily="34" charset="0"/>
+              </a:rPr>
+              <a:t>, bir planlı siparişe atanmış ancak henüz üretimde kullanılmamış;</a:t>
+            </a:r>
+            <a:br>
+              <a:rPr lang="tr-TR" sz="820" dirty="0">
+                <a:solidFill>
+                  <a:srgbClr val="66788A"/>
+                </a:solidFill>
+                <a:latin typeface="Aptos" panose="020B0004020202020204" pitchFamily="34" charset="0"/>
+              </a:rPr>
+            </a:br>
+            <a:r>
+              <a:rPr lang="tr-TR" sz="820" b="1" dirty="0" err="1">
+                <a:solidFill>
+                  <a:srgbClr val="66788A"/>
+                </a:solidFill>
+                <a:latin typeface="Aptos" panose="020B0004020202020204" pitchFamily="34" charset="0"/>
+              </a:rPr>
+              <a:t>ProducedOk</a:t>
+            </a:r>
+            <a:r>
+              <a:rPr lang="tr-TR" sz="820" dirty="0">
+                <a:solidFill>
+                  <a:srgbClr val="66788A"/>
+                </a:solidFill>
+                <a:latin typeface="Aptos" panose="020B0004020202020204" pitchFamily="34" charset="0"/>
+              </a:rPr>
+              <a:t>, üretimi başarıyla tamamlanan;</a:t>
+            </a:r>
+            <a:br>
+              <a:rPr lang="tr-TR" sz="820" dirty="0">
+                <a:solidFill>
+                  <a:srgbClr val="66788A"/>
+                </a:solidFill>
+                <a:latin typeface="Aptos" panose="020B0004020202020204" pitchFamily="34" charset="0"/>
+              </a:rPr>
+            </a:br>
+            <a:r>
+              <a:rPr lang="tr-TR" sz="820" b="1" dirty="0" err="1">
+                <a:solidFill>
+                  <a:srgbClr val="66788A"/>
+                </a:solidFill>
+                <a:latin typeface="Aptos" panose="020B0004020202020204" pitchFamily="34" charset="0"/>
+              </a:rPr>
+              <a:t>Reject</a:t>
+            </a:r>
+            <a:r>
+              <a:rPr lang="tr-TR" sz="820" b="1" dirty="0">
+                <a:solidFill>
+                  <a:srgbClr val="66788A"/>
+                </a:solidFill>
+                <a:latin typeface="Aptos" panose="020B0004020202020204" pitchFamily="34" charset="0"/>
+              </a:rPr>
+              <a:t> Kurtarma</a:t>
+            </a:r>
+            <a:r>
+              <a:rPr lang="tr-TR" sz="820" dirty="0">
+                <a:solidFill>
+                  <a:srgbClr val="66788A"/>
+                </a:solidFill>
+                <a:latin typeface="Aptos" panose="020B0004020202020204" pitchFamily="34" charset="0"/>
+              </a:rPr>
+              <a:t>, </a:t>
+            </a:r>
+            <a:r>
+              <a:rPr lang="tr-TR" sz="820" dirty="0" err="1">
+                <a:solidFill>
+                  <a:srgbClr val="66788A"/>
+                </a:solidFill>
+                <a:latin typeface="Aptos" panose="020B0004020202020204" pitchFamily="34" charset="0"/>
+              </a:rPr>
+              <a:t>reject</a:t>
+            </a:r>
+            <a:r>
+              <a:rPr lang="tr-TR" sz="820" dirty="0">
+                <a:solidFill>
+                  <a:srgbClr val="66788A"/>
+                </a:solidFill>
+                <a:latin typeface="Aptos" panose="020B0004020202020204" pitchFamily="34" charset="0"/>
+              </a:rPr>
+              <a:t> ünitesinden yeniden üretime kazandırılan;</a:t>
+            </a:r>
+            <a:br>
+              <a:rPr lang="tr-TR" sz="820" dirty="0">
+                <a:solidFill>
+                  <a:srgbClr val="66788A"/>
+                </a:solidFill>
+                <a:latin typeface="Aptos" panose="020B0004020202020204" pitchFamily="34" charset="0"/>
+              </a:rPr>
+            </a:br>
+            <a:r>
+              <a:rPr lang="tr-TR" sz="820" b="1" dirty="0" err="1">
+                <a:solidFill>
+                  <a:srgbClr val="66788A"/>
+                </a:solidFill>
+                <a:latin typeface="Aptos" panose="020B0004020202020204" pitchFamily="34" charset="0"/>
+              </a:rPr>
+              <a:t>Scrap</a:t>
+            </a:r>
+            <a:r>
+              <a:rPr lang="tr-TR" sz="820" b="1" dirty="0">
+                <a:solidFill>
+                  <a:srgbClr val="66788A"/>
+                </a:solidFill>
+                <a:latin typeface="Aptos" panose="020B0004020202020204" pitchFamily="34" charset="0"/>
+              </a:rPr>
+              <a:t> </a:t>
+            </a:r>
+            <a:r>
+              <a:rPr lang="tr-TR" sz="820" dirty="0">
+                <a:solidFill>
+                  <a:srgbClr val="66788A"/>
+                </a:solidFill>
+                <a:latin typeface="Aptos" panose="020B0004020202020204" pitchFamily="34" charset="0"/>
+              </a:rPr>
+              <a:t>ise fireye ayrılan kodları ifade eder.</a:t>
             </a:r>
           </a:p>
         </p:txBody>
@@ -13849,7 +13853,7 @@
           <a:lstStyle/>
           <a:p>
             <a:r>
-              <a:rPr lang="tr-TR" sz="820">
+              <a:rPr lang="tr-TR" sz="820" dirty="0">
                 <a:solidFill>
                   <a:srgbClr val="66788A"/>
                 </a:solidFill>
@@ -14272,7 +14276,7 @@
         </p:nvSpPr>
         <p:spPr>
           <a:xfrm>
-            <a:off x="10652760" y="1572768"/>
+            <a:off x="11123676" y="1929384"/>
             <a:ext cx="329184" cy="329184"/>
           </a:xfrm>
           <a:prstGeom prst="ellipse">
@@ -14334,7 +14338,7 @@
         </p:nvSpPr>
         <p:spPr>
           <a:xfrm>
-            <a:off x="7726680" y="2779776"/>
+            <a:off x="9464040" y="2803975"/>
             <a:ext cx="329184" cy="329184"/>
           </a:xfrm>
           <a:prstGeom prst="ellipse">
@@ -14396,7 +14400,7 @@
         </p:nvSpPr>
         <p:spPr>
           <a:xfrm>
-            <a:off x="10515600" y="2788920"/>
+            <a:off x="10689336" y="2799403"/>
             <a:ext cx="329184" cy="329184"/>
           </a:xfrm>
           <a:prstGeom prst="ellipse">
@@ -14575,7 +14579,7 @@
           <a:lstStyle/>
           <a:p>
             <a:r>
-              <a:rPr lang="tr-TR" sz="780">
+              <a:rPr lang="tr-TR" sz="780" dirty="0">
                 <a:solidFill>
                   <a:srgbClr val="66788A"/>
                 </a:solidFill>
@@ -14703,7 +14707,7 @@
         <p:spPr>
           <a:xfrm>
             <a:off x="4663440" y="5202936"/>
-            <a:ext cx="3182112" cy="276999"/>
+            <a:ext cx="3182112" cy="401695"/>
           </a:xfrm>
           <a:prstGeom prst="rect">
             <a:avLst/>
@@ -14717,13 +14721,58 @@
           <a:lstStyle/>
           <a:p>
             <a:r>
-              <a:rPr lang="tr-TR" sz="780">
+              <a:rPr lang="tr-TR" sz="780" b="1" dirty="0">
                 <a:solidFill>
                   <a:srgbClr val="66788A"/>
                 </a:solidFill>
                 <a:latin typeface="Aptos" panose="020B0004020202020204" pitchFamily="34" charset="0"/>
               </a:rPr>
-              <a:t>PASİF hazırlık, AKTİF üretim, TAMAMLANDI biten süreçtir. Aynı anda yalnızca bir sipariş aktif olabilir.</a:t>
+              <a:t>Pasif</a:t>
+            </a:r>
+            <a:r>
+              <a:rPr lang="tr-TR" sz="780" dirty="0">
+                <a:solidFill>
+                  <a:srgbClr val="66788A"/>
+                </a:solidFill>
+                <a:latin typeface="Aptos" panose="020B0004020202020204" pitchFamily="34" charset="0"/>
+              </a:rPr>
+              <a:t>, henüz üretime başlanmamış siparişi; </a:t>
+            </a:r>
+            <a:r>
+              <a:rPr lang="tr-TR" sz="780" b="1" dirty="0">
+                <a:solidFill>
+                  <a:srgbClr val="66788A"/>
+                </a:solidFill>
+                <a:latin typeface="Aptos" panose="020B0004020202020204" pitchFamily="34" charset="0"/>
+              </a:rPr>
+              <a:t>Aktif</a:t>
+            </a:r>
+            <a:r>
+              <a:rPr lang="tr-TR" sz="780" dirty="0">
+                <a:solidFill>
+                  <a:srgbClr val="66788A"/>
+                </a:solidFill>
+                <a:latin typeface="Aptos" panose="020B0004020202020204" pitchFamily="34" charset="0"/>
+              </a:rPr>
+              <a:t>, üretimi devam eden siparişi; </a:t>
+            </a:r>
+            <a:r>
+              <a:rPr lang="tr-TR" sz="780" b="1" dirty="0">
+                <a:solidFill>
+                  <a:srgbClr val="66788A"/>
+                </a:solidFill>
+                <a:latin typeface="Aptos" panose="020B0004020202020204" pitchFamily="34" charset="0"/>
+              </a:rPr>
+              <a:t>Tamamlandı</a:t>
+            </a:r>
+            <a:r>
+              <a:rPr lang="tr-TR" sz="780" dirty="0">
+                <a:solidFill>
+                  <a:srgbClr val="66788A"/>
+                </a:solidFill>
+                <a:latin typeface="Aptos" panose="020B0004020202020204" pitchFamily="34" charset="0"/>
+              </a:rPr>
+              <a:t> ise üretim süreci sonuçlandırılmış siparişi ifade eder. Aynı anda yalnızca bir sipariş aktif olabilir.</a:t>
             </a:r>
           </a:p>
         </p:txBody>
@@ -14859,7 +14908,7 @@
           <a:lstStyle/>
           <a:p>
             <a:r>
-              <a:rPr lang="tr-TR" sz="780">
+              <a:rPr lang="tr-TR" sz="780" dirty="0">
                 <a:solidFill>
                   <a:srgbClr val="66788A"/>
                 </a:solidFill>
@@ -15282,7 +15331,7 @@
         </p:nvSpPr>
         <p:spPr>
           <a:xfrm>
-            <a:off x="9674352" y="1645920"/>
+            <a:off x="10040112" y="1591869"/>
             <a:ext cx="310896" cy="310896"/>
           </a:xfrm>
           <a:prstGeom prst="ellipse">
@@ -15344,7 +15393,7 @@
         </p:nvSpPr>
         <p:spPr>
           <a:xfrm>
-            <a:off x="9674352" y="2468880"/>
+            <a:off x="9886800" y="2167941"/>
             <a:ext cx="310896" cy="310896"/>
           </a:xfrm>
           <a:prstGeom prst="ellipse">
@@ -15381,7 +15430,7 @@
           <a:p>
             <a:pPr algn="ctr"/>
             <a:r>
-              <a:rPr lang="tr-TR" sz="900" b="1">
+              <a:rPr lang="tr-TR" sz="900" b="1" dirty="0">
                 <a:solidFill>
                   <a:srgbClr val="FFFFFF"/>
                 </a:solidFill>
@@ -15406,7 +15455,7 @@
         </p:nvSpPr>
         <p:spPr>
           <a:xfrm>
-            <a:off x="9674352" y="3246120"/>
+            <a:off x="9970293" y="2843784"/>
             <a:ext cx="310896" cy="310896"/>
           </a:xfrm>
           <a:prstGeom prst="ellipse">
@@ -15468,7 +15517,7 @@
         </p:nvSpPr>
         <p:spPr>
           <a:xfrm>
-            <a:off x="9674352" y="3977640"/>
+            <a:off x="9970293" y="3439483"/>
             <a:ext cx="310896" cy="310896"/>
           </a:xfrm>
           <a:prstGeom prst="ellipse">
@@ -15530,7 +15579,7 @@
         </p:nvSpPr>
         <p:spPr>
           <a:xfrm>
-            <a:off x="9674352" y="5120640"/>
+            <a:off x="9970293" y="4167756"/>
             <a:ext cx="310896" cy="310896"/>
           </a:xfrm>
           <a:prstGeom prst="ellipse">
@@ -16700,7 +16749,7 @@
         </p:nvSpPr>
         <p:spPr>
           <a:xfrm>
-            <a:off x="10561320" y="2514600"/>
+            <a:off x="10890503" y="2798064"/>
             <a:ext cx="329183" cy="329184"/>
           </a:xfrm>
           <a:prstGeom prst="ellipse">
@@ -16737,7 +16786,7 @@
           <a:p>
             <a:pPr algn="ctr"/>
             <a:r>
-              <a:rPr lang="tr-TR" sz="900" b="1">
+              <a:rPr lang="tr-TR" sz="900" b="1" dirty="0">
                 <a:solidFill>
                   <a:srgbClr val="FFFFFF"/>
                 </a:solidFill>
@@ -16762,7 +16811,7 @@
         </p:nvSpPr>
         <p:spPr>
           <a:xfrm>
-            <a:off x="10561320" y="3246120"/>
+            <a:off x="10890502" y="3325183"/>
             <a:ext cx="329183" cy="329184"/>
           </a:xfrm>
           <a:prstGeom prst="ellipse">
@@ -16824,7 +16873,7 @@
         </p:nvSpPr>
         <p:spPr>
           <a:xfrm>
-            <a:off x="8092440" y="3977640"/>
+            <a:off x="10887456" y="3954780"/>
             <a:ext cx="329184" cy="329184"/>
           </a:xfrm>
           <a:prstGeom prst="ellipse">
@@ -17710,7 +17759,7 @@
         </p:nvSpPr>
         <p:spPr>
           <a:xfrm>
-            <a:off x="2743200" y="2057400"/>
+            <a:off x="5687568" y="2303606"/>
             <a:ext cx="329184" cy="329184"/>
           </a:xfrm>
           <a:prstGeom prst="ellipse">
@@ -17747,7 +17796,7 @@
           <a:p>
             <a:pPr algn="ctr"/>
             <a:r>
-              <a:rPr lang="tr-TR" sz="900" b="1">
+              <a:rPr lang="tr-TR" sz="900" b="1" dirty="0">
                 <a:solidFill>
                   <a:srgbClr val="FFFFFF"/>
                 </a:solidFill>
@@ -17772,7 +17821,7 @@
         </p:nvSpPr>
         <p:spPr>
           <a:xfrm>
-            <a:off x="6766560" y="2834640"/>
+            <a:off x="11036808" y="2303606"/>
             <a:ext cx="329184" cy="329184"/>
           </a:xfrm>
           <a:prstGeom prst="ellipse">
@@ -17809,7 +17858,7 @@
           <a:p>
             <a:pPr algn="ctr"/>
             <a:r>
-              <a:rPr lang="tr-TR" sz="900" b="1">
+              <a:rPr lang="tr-TR" sz="900" b="1" dirty="0">
                 <a:solidFill>
                   <a:srgbClr val="FFFFFF"/>
                 </a:solidFill>
@@ -17834,7 +17883,7 @@
         </p:nvSpPr>
         <p:spPr>
           <a:xfrm>
-            <a:off x="9738360" y="3840480"/>
+            <a:off x="10305288" y="3749723"/>
             <a:ext cx="329184" cy="329184"/>
           </a:xfrm>
           <a:prstGeom prst="ellipse">
@@ -17896,7 +17945,7 @@
         </p:nvSpPr>
         <p:spPr>
           <a:xfrm>
-            <a:off x="10469880" y="4526280"/>
+            <a:off x="11036808" y="4151376"/>
             <a:ext cx="329184" cy="329184"/>
           </a:xfrm>
           <a:prstGeom prst="ellipse">
@@ -18924,7 +18973,7 @@
         </p:nvSpPr>
         <p:spPr>
           <a:xfrm>
-            <a:off x="5623560" y="1920240"/>
+            <a:off x="7539228" y="2506795"/>
             <a:ext cx="329184" cy="329184"/>
           </a:xfrm>
           <a:prstGeom prst="ellipse">
@@ -18961,7 +19010,7 @@
           <a:p>
             <a:pPr algn="ctr"/>
             <a:r>
-              <a:rPr lang="tr-TR" sz="900" b="1">
+              <a:rPr lang="tr-TR" sz="900" b="1" dirty="0">
                 <a:solidFill>
                   <a:srgbClr val="FFFFFF"/>
                 </a:solidFill>
@@ -18986,7 +19035,7 @@
         </p:nvSpPr>
         <p:spPr>
           <a:xfrm>
-            <a:off x="4663440" y="3154680"/>
+            <a:off x="7539228" y="3484305"/>
             <a:ext cx="329184" cy="329184"/>
           </a:xfrm>
           <a:prstGeom prst="ellipse">
@@ -19048,7 +19097,7 @@
         </p:nvSpPr>
         <p:spPr>
           <a:xfrm>
-            <a:off x="4023360" y="4297680"/>
+            <a:off x="7543800" y="4471416"/>
             <a:ext cx="329184" cy="329184"/>
           </a:xfrm>
           <a:prstGeom prst="ellipse">
@@ -19110,7 +19159,7 @@
         </p:nvSpPr>
         <p:spPr>
           <a:xfrm>
-            <a:off x="6995160" y="5257800"/>
+            <a:off x="7539228" y="5120640"/>
             <a:ext cx="329184" cy="329184"/>
           </a:xfrm>
           <a:prstGeom prst="ellipse">
@@ -20200,7 +20249,7 @@
         </p:nvSpPr>
         <p:spPr>
           <a:xfrm>
-            <a:off x="2743200" y="2331720"/>
+            <a:off x="4023360" y="2718447"/>
             <a:ext cx="329184" cy="329184"/>
           </a:xfrm>
           <a:prstGeom prst="ellipse">
@@ -20237,7 +20286,7 @@
           <a:p>
             <a:pPr algn="ctr"/>
             <a:r>
-              <a:rPr lang="tr-TR" sz="900" b="1">
+              <a:rPr lang="tr-TR" sz="900" b="1" dirty="0">
                 <a:solidFill>
                   <a:srgbClr val="FFFFFF"/>
                 </a:solidFill>
@@ -20262,7 +20311,7 @@
         </p:nvSpPr>
         <p:spPr>
           <a:xfrm>
-            <a:off x="3429000" y="3703320"/>
+            <a:off x="4023360" y="3986667"/>
             <a:ext cx="329184" cy="329184"/>
           </a:xfrm>
           <a:prstGeom prst="ellipse">
@@ -20299,7 +20348,7 @@
           <a:p>
             <a:pPr algn="ctr"/>
             <a:r>
-              <a:rPr lang="tr-TR" sz="900" b="1">
+              <a:rPr lang="tr-TR" sz="900" b="1" dirty="0">
                 <a:solidFill>
                   <a:srgbClr val="FFFFFF"/>
                 </a:solidFill>
@@ -20324,7 +20373,7 @@
         </p:nvSpPr>
         <p:spPr>
           <a:xfrm>
-            <a:off x="3429000" y="5074920"/>
+            <a:off x="4023360" y="4852551"/>
             <a:ext cx="329184" cy="329184"/>
           </a:xfrm>
           <a:prstGeom prst="ellipse">

</xml_diff>